<commit_message>
Expand demonstration patient data
</commit_message>
<xml_diff>
--- a/E-presentation.pptx
+++ b/E-presentation.pptx
@@ -7583,7 +7583,7 @@
         </p:nvSpPr>
         <p:spPr>
           <a:xfrm>
-            <a:off x="3556000" y="3124200"/>
+            <a:off x="3556000" y="3309322"/>
             <a:ext cx="1193800" cy="153888"/>
           </a:xfrm>
           <a:prstGeom prst="rect">
@@ -7624,7 +7624,7 @@
         </p:nvSpPr>
         <p:spPr>
           <a:xfrm>
-            <a:off x="8610600" y="3035300"/>
+            <a:off x="8864600" y="3015506"/>
             <a:ext cx="2413000" cy="153888"/>
           </a:xfrm>
           <a:prstGeom prst="rect">
@@ -7640,7 +7640,7 @@
           <a:p>
             <a:pPr algn="ctr"/>
             <a:r>
-              <a:rPr lang="en-US" sz="1000">
+              <a:rPr lang="en-US" sz="1000" dirty="0">
                 <a:solidFill>
                   <a:srgbClr val="475569"/>
                 </a:solidFill>

</xml_diff>

<commit_message>
Correct final presentation slide count
</commit_message>
<xml_diff>
--- a/E-presentation.pptx
+++ b/E-presentation.pptx
@@ -5,7 +5,7 @@
     <p:sldMasterId id="2147483648" r:id="rId1"/>
   </p:sldMasterIdLst>
   <p:notesMasterIdLst>
-    <p:notesMasterId r:id="rId11"/>
+    <p:notesMasterId r:id="rId10"/>
   </p:notesMasterIdLst>
   <p:sldIdLst>
     <p:sldId id="256" r:id="rId2"/>
@@ -16,7 +16,6 @@
     <p:sldId id="261" r:id="rId7"/>
     <p:sldId id="262" r:id="rId8"/>
     <p:sldId id="263" r:id="rId9"/>
-    <p:sldId id="264" r:id="rId10"/>
   </p:sldIdLst>
   <p:sldSz cx="12192000" cy="6858000"/>
   <p:notesSz cx="6858000" cy="9144000"/>
@@ -11583,7 +11582,7 @@
                 </a:solidFill>
                 <a:latin typeface="Aptos" panose="020B0004020202020204" pitchFamily="34" charset="0"/>
               </a:rPr>
-              <a:t>15 / 15</a:t>
+              <a:t>16 / 16</a:t>
             </a:r>
           </a:p>
         </p:txBody>
@@ -11898,1217 +11897,6 @@
     <p:extLst>
       <p:ext uri="{BB962C8B-B14F-4D97-AF65-F5344CB8AC3E}">
         <p14:creationId xmlns:p14="http://schemas.microsoft.com/office/powerpoint/2010/main" val="2664732094"/>
-      </p:ext>
-    </p:extLst>
-  </p:cSld>
-  <p:clrMapOvr>
-    <a:masterClrMapping/>
-  </p:clrMapOvr>
-</p:sld>
-</file>
-
-<file path=ppt/slides/slide9.xml><?xml version="1.0" encoding="utf-8"?>
-<p:sld xmlns:a="http://schemas.openxmlformats.org/drawingml/2006/main" xmlns:r="http://schemas.openxmlformats.org/officeDocument/2006/relationships" xmlns:p="http://schemas.openxmlformats.org/presentationml/2006/main">
-  <p:cSld>
-    <p:bg>
-      <p:bgPr>
-        <a:solidFill>
-          <a:schemeClr val="bg1"/>
-        </a:solidFill>
-        <a:effectLst/>
-      </p:bgPr>
-    </p:bg>
-    <p:spTree>
-      <p:nvGrpSpPr>
-        <p:cNvPr id="1" name=""/>
-        <p:cNvGrpSpPr/>
-        <p:nvPr/>
-      </p:nvGrpSpPr>
-      <p:grpSpPr>
-        <a:xfrm>
-          <a:off x="0" y="0"/>
-          <a:ext cx="0" cy="0"/>
-          <a:chOff x="0" y="0"/>
-          <a:chExt cx="0" cy="0"/>
-        </a:xfrm>
-      </p:grpSpPr>
-      <p:sp>
-        <p:nvSpPr>
-          <p:cNvPr id="7" name="Rectangle 6">
-            <a:extLst>
-              <a:ext uri="{FF2B5EF4-FFF2-40B4-BE49-F238E27FC236}">
-                <a16:creationId xmlns:a16="http://schemas.microsoft.com/office/drawing/2014/main" id="{8F9CBE3F-79A8-4F8F-88D9-DAD03D0D281F}"/>
-              </a:ext>
-              <a:ext uri="{C183D7F6-B498-43B3-948B-1728B52AA6E4}">
-                <adec:decorative xmlns:adec="http://schemas.microsoft.com/office/drawing/2017/decorative" val="1"/>
-              </a:ext>
-            </a:extLst>
-          </p:cNvPr>
-          <p:cNvSpPr>
-            <a:spLocks noGrp="1" noRot="1" noChangeAspect="1" noMove="1" noResize="1" noEditPoints="1" noAdjustHandles="1" noChangeArrowheads="1" noChangeShapeType="1" noTextEdit="1"/>
-          </p:cNvSpPr>
-          <p:nvPr>
-            <p:extLst>
-              <p:ext uri="{386F3935-93C4-4BCD-93E2-E3B085C9AB24}">
-                <p16:designElem xmlns:p16="http://schemas.microsoft.com/office/powerpoint/2015/main" val="1"/>
-              </p:ext>
-            </p:extLst>
-          </p:nvPr>
-        </p:nvSpPr>
-        <p:spPr>
-          <a:xfrm>
-            <a:off x="0" y="0"/>
-            <a:ext cx="12192000" cy="6858000"/>
-          </a:xfrm>
-          <a:prstGeom prst="rect">
-            <a:avLst/>
-          </a:prstGeom>
-          <a:gradFill flip="none" rotWithShape="1">
-            <a:gsLst>
-              <a:gs pos="0">
-                <a:schemeClr val="accent1"/>
-              </a:gs>
-              <a:gs pos="100000">
-                <a:schemeClr val="accent2"/>
-              </a:gs>
-            </a:gsLst>
-            <a:lin ang="2700000" scaled="1"/>
-            <a:tileRect/>
-          </a:gradFill>
-          <a:ln>
-            <a:noFill/>
-          </a:ln>
-        </p:spPr>
-        <p:style>
-          <a:lnRef idx="2">
-            <a:schemeClr val="accent1">
-              <a:shade val="50000"/>
-            </a:schemeClr>
-          </a:lnRef>
-          <a:fillRef idx="1">
-            <a:schemeClr val="accent1"/>
-          </a:fillRef>
-          <a:effectRef idx="0">
-            <a:schemeClr val="accent1"/>
-          </a:effectRef>
-          <a:fontRef idx="minor">
-            <a:schemeClr val="lt1"/>
-          </a:fontRef>
-        </p:style>
-        <p:txBody>
-          <a:bodyPr rtlCol="0" anchor="ctr"/>
-          <a:lstStyle/>
-          <a:p>
-            <a:pPr algn="ctr"/>
-            <a:endParaRPr lang="en-US">
-              <a:solidFill>
-                <a:srgbClr val="FFFFFF"/>
-              </a:solidFill>
-            </a:endParaRPr>
-          </a:p>
-        </p:txBody>
-      </p:sp>
-      <p:sp>
-        <p:nvSpPr>
-          <p:cNvPr id="2" name="Title 1">
-            <a:extLst>
-              <a:ext uri="{FF2B5EF4-FFF2-40B4-BE49-F238E27FC236}">
-                <a16:creationId xmlns:a16="http://schemas.microsoft.com/office/drawing/2014/main" id="{FDE6DA70-4600-CAA8-5F48-7D1EFABDECC4}"/>
-              </a:ext>
-            </a:extLst>
-          </p:cNvPr>
-          <p:cNvSpPr>
-            <a:spLocks noGrp="1"/>
-          </p:cNvSpPr>
-          <p:nvPr>
-            <p:ph type="title"/>
-          </p:nvPr>
-        </p:nvSpPr>
-        <p:spPr>
-          <a:xfrm>
-            <a:off x="1522030" y="1209220"/>
-            <a:ext cx="9147940" cy="2337238"/>
-          </a:xfrm>
-        </p:spPr>
-        <p:txBody>
-          <a:bodyPr vert="horz" lIns="91440" tIns="45720" rIns="91440" bIns="45720" rtlCol="0" anchor="b">
-            <a:normAutofit/>
-          </a:bodyPr>
-          <a:lstStyle/>
-          <a:p>
-            <a:pPr algn="ctr"/>
-            <a:r>
-              <a:rPr lang="en-US" sz="5200" kern="1200">
-                <a:solidFill>
-                  <a:srgbClr val="FFFFFF"/>
-                </a:solidFill>
-                <a:latin typeface="+mj-lt"/>
-                <a:ea typeface="+mj-ea"/>
-                <a:cs typeface="+mj-cs"/>
-              </a:rPr>
-              <a:t>The End</a:t>
-            </a:r>
-            <a:br>
-              <a:rPr lang="en-US" sz="5200" kern="1200">
-                <a:solidFill>
-                  <a:srgbClr val="FFFFFF"/>
-                </a:solidFill>
-                <a:latin typeface="+mj-lt"/>
-                <a:ea typeface="+mj-ea"/>
-                <a:cs typeface="+mj-cs"/>
-              </a:rPr>
-            </a:br>
-            <a:br>
-              <a:rPr lang="en-US" sz="5200" kern="1200">
-                <a:solidFill>
-                  <a:srgbClr val="FFFFFF"/>
-                </a:solidFill>
-                <a:latin typeface="+mj-lt"/>
-                <a:ea typeface="+mj-ea"/>
-                <a:cs typeface="+mj-cs"/>
-              </a:rPr>
-            </a:br>
-            <a:r>
-              <a:rPr lang="en-US" sz="5200" kern="1200">
-                <a:solidFill>
-                  <a:srgbClr val="FFFFFF"/>
-                </a:solidFill>
-                <a:latin typeface="+mj-lt"/>
-                <a:ea typeface="+mj-ea"/>
-                <a:cs typeface="+mj-cs"/>
-              </a:rPr>
-              <a:t>Thank you.</a:t>
-            </a:r>
-          </a:p>
-        </p:txBody>
-      </p:sp>
-      <p:sp>
-        <p:nvSpPr>
-          <p:cNvPr id="9" name="Graphic 22">
-            <a:extLst>
-              <a:ext uri="{FF2B5EF4-FFF2-40B4-BE49-F238E27FC236}">
-                <a16:creationId xmlns:a16="http://schemas.microsoft.com/office/drawing/2014/main" id="{508BEF50-7B1E-49A4-BC19-5F4F1D755E64}"/>
-              </a:ext>
-              <a:ext uri="{C183D7F6-B498-43B3-948B-1728B52AA6E4}">
-                <adec:decorative xmlns:adec="http://schemas.microsoft.com/office/drawing/2017/decorative" val="1"/>
-              </a:ext>
-            </a:extLst>
-          </p:cNvPr>
-          <p:cNvSpPr>
-            <a:spLocks noGrp="1" noRot="1" noChangeAspect="1" noMove="1" noResize="1" noEditPoints="1" noAdjustHandles="1" noChangeArrowheads="1" noChangeShapeType="1" noTextEdit="1"/>
-          </p:cNvSpPr>
-          <p:nvPr>
-            <p:extLst>
-              <p:ext uri="{386F3935-93C4-4BCD-93E2-E3B085C9AB24}">
-                <p16:designElem xmlns:p16="http://schemas.microsoft.com/office/powerpoint/2015/main" val="1"/>
-              </p:ext>
-            </p:extLst>
-          </p:nvPr>
-        </p:nvSpPr>
-        <p:spPr>
-          <a:xfrm>
-            <a:off x="1261869" y="2383077"/>
-            <a:ext cx="151536" cy="151536"/>
-          </a:xfrm>
-          <a:custGeom>
-            <a:avLst/>
-            <a:gdLst>
-              <a:gd name="connsiteX0" fmla="*/ 141251 w 151536"/>
-              <a:gd name="connsiteY0" fmla="*/ 65483 h 151536"/>
-              <a:gd name="connsiteX1" fmla="*/ 86053 w 151536"/>
-              <a:gd name="connsiteY1" fmla="*/ 65483 h 151536"/>
-              <a:gd name="connsiteX2" fmla="*/ 86053 w 151536"/>
-              <a:gd name="connsiteY2" fmla="*/ 10285 h 151536"/>
-              <a:gd name="connsiteX3" fmla="*/ 75768 w 151536"/>
-              <a:gd name="connsiteY3" fmla="*/ 0 h 151536"/>
-              <a:gd name="connsiteX4" fmla="*/ 65483 w 151536"/>
-              <a:gd name="connsiteY4" fmla="*/ 10285 h 151536"/>
-              <a:gd name="connsiteX5" fmla="*/ 65483 w 151536"/>
-              <a:gd name="connsiteY5" fmla="*/ 65483 h 151536"/>
-              <a:gd name="connsiteX6" fmla="*/ 10285 w 151536"/>
-              <a:gd name="connsiteY6" fmla="*/ 65483 h 151536"/>
-              <a:gd name="connsiteX7" fmla="*/ 0 w 151536"/>
-              <a:gd name="connsiteY7" fmla="*/ 75768 h 151536"/>
-              <a:gd name="connsiteX8" fmla="*/ 10285 w 151536"/>
-              <a:gd name="connsiteY8" fmla="*/ 86053 h 151536"/>
-              <a:gd name="connsiteX9" fmla="*/ 65483 w 151536"/>
-              <a:gd name="connsiteY9" fmla="*/ 86053 h 151536"/>
-              <a:gd name="connsiteX10" fmla="*/ 65483 w 151536"/>
-              <a:gd name="connsiteY10" fmla="*/ 141251 h 151536"/>
-              <a:gd name="connsiteX11" fmla="*/ 75768 w 151536"/>
-              <a:gd name="connsiteY11" fmla="*/ 151536 h 151536"/>
-              <a:gd name="connsiteX12" fmla="*/ 86053 w 151536"/>
-              <a:gd name="connsiteY12" fmla="*/ 141251 h 151536"/>
-              <a:gd name="connsiteX13" fmla="*/ 86053 w 151536"/>
-              <a:gd name="connsiteY13" fmla="*/ 86053 h 151536"/>
-              <a:gd name="connsiteX14" fmla="*/ 141251 w 151536"/>
-              <a:gd name="connsiteY14" fmla="*/ 86053 h 151536"/>
-              <a:gd name="connsiteX15" fmla="*/ 151536 w 151536"/>
-              <a:gd name="connsiteY15" fmla="*/ 75768 h 151536"/>
-              <a:gd name="connsiteX16" fmla="*/ 141251 w 151536"/>
-              <a:gd name="connsiteY16" fmla="*/ 65483 h 151536"/>
-            </a:gdLst>
-            <a:ahLst/>
-            <a:cxnLst>
-              <a:cxn ang="0">
-                <a:pos x="connsiteX0" y="connsiteY0"/>
-              </a:cxn>
-              <a:cxn ang="0">
-                <a:pos x="connsiteX1" y="connsiteY1"/>
-              </a:cxn>
-              <a:cxn ang="0">
-                <a:pos x="connsiteX2" y="connsiteY2"/>
-              </a:cxn>
-              <a:cxn ang="0">
-                <a:pos x="connsiteX3" y="connsiteY3"/>
-              </a:cxn>
-              <a:cxn ang="0">
-                <a:pos x="connsiteX4" y="connsiteY4"/>
-              </a:cxn>
-              <a:cxn ang="0">
-                <a:pos x="connsiteX5" y="connsiteY5"/>
-              </a:cxn>
-              <a:cxn ang="0">
-                <a:pos x="connsiteX6" y="connsiteY6"/>
-              </a:cxn>
-              <a:cxn ang="0">
-                <a:pos x="connsiteX7" y="connsiteY7"/>
-              </a:cxn>
-              <a:cxn ang="0">
-                <a:pos x="connsiteX8" y="connsiteY8"/>
-              </a:cxn>
-              <a:cxn ang="0">
-                <a:pos x="connsiteX9" y="connsiteY9"/>
-              </a:cxn>
-              <a:cxn ang="0">
-                <a:pos x="connsiteX10" y="connsiteY10"/>
-              </a:cxn>
-              <a:cxn ang="0">
-                <a:pos x="connsiteX11" y="connsiteY11"/>
-              </a:cxn>
-              <a:cxn ang="0">
-                <a:pos x="connsiteX12" y="connsiteY12"/>
-              </a:cxn>
-              <a:cxn ang="0">
-                <a:pos x="connsiteX13" y="connsiteY13"/>
-              </a:cxn>
-              <a:cxn ang="0">
-                <a:pos x="connsiteX14" y="connsiteY14"/>
-              </a:cxn>
-              <a:cxn ang="0">
-                <a:pos x="connsiteX15" y="connsiteY15"/>
-              </a:cxn>
-              <a:cxn ang="0">
-                <a:pos x="connsiteX16" y="connsiteY16"/>
-              </a:cxn>
-            </a:cxnLst>
-            <a:rect l="l" t="t" r="r" b="b"/>
-            <a:pathLst>
-              <a:path w="151536" h="151536">
-                <a:moveTo>
-                  <a:pt x="141251" y="65483"/>
-                </a:moveTo>
-                <a:lnTo>
-                  <a:pt x="86053" y="65483"/>
-                </a:lnTo>
-                <a:lnTo>
-                  <a:pt x="86053" y="10285"/>
-                </a:lnTo>
-                <a:cubicBezTo>
-                  <a:pt x="86053" y="4605"/>
-                  <a:pt x="81448" y="0"/>
-                  <a:pt x="75768" y="0"/>
-                </a:cubicBezTo>
-                <a:cubicBezTo>
-                  <a:pt x="70088" y="0"/>
-                  <a:pt x="65483" y="4605"/>
-                  <a:pt x="65483" y="10285"/>
-                </a:cubicBezTo>
-                <a:lnTo>
-                  <a:pt x="65483" y="65483"/>
-                </a:lnTo>
-                <a:lnTo>
-                  <a:pt x="10285" y="65483"/>
-                </a:lnTo>
-                <a:cubicBezTo>
-                  <a:pt x="4605" y="65483"/>
-                  <a:pt x="0" y="70088"/>
-                  <a:pt x="0" y="75768"/>
-                </a:cubicBezTo>
-                <a:cubicBezTo>
-                  <a:pt x="0" y="81448"/>
-                  <a:pt x="4605" y="86053"/>
-                  <a:pt x="10285" y="86053"/>
-                </a:cubicBezTo>
-                <a:lnTo>
-                  <a:pt x="65483" y="86053"/>
-                </a:lnTo>
-                <a:lnTo>
-                  <a:pt x="65483" y="141251"/>
-                </a:lnTo>
-                <a:cubicBezTo>
-                  <a:pt x="65483" y="146931"/>
-                  <a:pt x="70088" y="151536"/>
-                  <a:pt x="75768" y="151536"/>
-                </a:cubicBezTo>
-                <a:cubicBezTo>
-                  <a:pt x="81448" y="151536"/>
-                  <a:pt x="86053" y="146931"/>
-                  <a:pt x="86053" y="141251"/>
-                </a:cubicBezTo>
-                <a:lnTo>
-                  <a:pt x="86053" y="86053"/>
-                </a:lnTo>
-                <a:lnTo>
-                  <a:pt x="141251" y="86053"/>
-                </a:lnTo>
-                <a:cubicBezTo>
-                  <a:pt x="146931" y="86053"/>
-                  <a:pt x="151536" y="81448"/>
-                  <a:pt x="151536" y="75768"/>
-                </a:cubicBezTo>
-                <a:cubicBezTo>
-                  <a:pt x="151536" y="70088"/>
-                  <a:pt x="146931" y="65483"/>
-                  <a:pt x="141251" y="65483"/>
-                </a:cubicBezTo>
-                <a:close/>
-              </a:path>
-            </a:pathLst>
-          </a:custGeom>
-          <a:solidFill>
-            <a:srgbClr val="FFFFFF"/>
-          </a:solidFill>
-          <a:ln w="646" cap="flat">
-            <a:noFill/>
-            <a:prstDash val="solid"/>
-            <a:miter/>
-          </a:ln>
-        </p:spPr>
-        <p:txBody>
-          <a:bodyPr rtlCol="0" anchor="ctr"/>
-          <a:lstStyle/>
-          <a:p>
-            <a:endParaRPr lang="en-US">
-              <a:solidFill>
-                <a:srgbClr val="FFFFFF"/>
-              </a:solidFill>
-            </a:endParaRPr>
-          </a:p>
-        </p:txBody>
-      </p:sp>
-      <p:sp>
-        <p:nvSpPr>
-          <p:cNvPr id="11" name="Graphic 13">
-            <a:extLst>
-              <a:ext uri="{FF2B5EF4-FFF2-40B4-BE49-F238E27FC236}">
-                <a16:creationId xmlns:a16="http://schemas.microsoft.com/office/drawing/2014/main" id="{C5CB530E-515E-412C-9DF1-5F8FFBD6F383}"/>
-              </a:ext>
-              <a:ext uri="{C183D7F6-B498-43B3-948B-1728B52AA6E4}">
-                <adec:decorative xmlns:adec="http://schemas.microsoft.com/office/drawing/2017/decorative" val="1"/>
-              </a:ext>
-            </a:extLst>
-          </p:cNvPr>
-          <p:cNvSpPr>
-            <a:spLocks noGrp="1" noRot="1" noChangeAspect="1" noMove="1" noResize="1" noEditPoints="1" noAdjustHandles="1" noChangeArrowheads="1" noChangeShapeType="1" noTextEdit="1"/>
-          </p:cNvSpPr>
-          <p:nvPr>
-            <p:extLst>
-              <p:ext uri="{386F3935-93C4-4BCD-93E2-E3B085C9AB24}">
-                <p16:designElem xmlns:p16="http://schemas.microsoft.com/office/powerpoint/2015/main" val="1"/>
-              </p:ext>
-            </p:extLst>
-          </p:nvPr>
-        </p:nvSpPr>
-        <p:spPr>
-          <a:xfrm>
-            <a:off x="10724364" y="2265467"/>
-            <a:ext cx="139039" cy="139039"/>
-          </a:xfrm>
-          <a:custGeom>
-            <a:avLst/>
-            <a:gdLst>
-              <a:gd name="connsiteX0" fmla="*/ 129602 w 139039"/>
-              <a:gd name="connsiteY0" fmla="*/ 60082 h 139039"/>
-              <a:gd name="connsiteX1" fmla="*/ 78957 w 139039"/>
-              <a:gd name="connsiteY1" fmla="*/ 60082 h 139039"/>
-              <a:gd name="connsiteX2" fmla="*/ 78957 w 139039"/>
-              <a:gd name="connsiteY2" fmla="*/ 9437 h 139039"/>
-              <a:gd name="connsiteX3" fmla="*/ 69520 w 139039"/>
-              <a:gd name="connsiteY3" fmla="*/ 0 h 139039"/>
-              <a:gd name="connsiteX4" fmla="*/ 60082 w 139039"/>
-              <a:gd name="connsiteY4" fmla="*/ 9437 h 139039"/>
-              <a:gd name="connsiteX5" fmla="*/ 60082 w 139039"/>
-              <a:gd name="connsiteY5" fmla="*/ 60082 h 139039"/>
-              <a:gd name="connsiteX6" fmla="*/ 9437 w 139039"/>
-              <a:gd name="connsiteY6" fmla="*/ 60082 h 139039"/>
-              <a:gd name="connsiteX7" fmla="*/ 0 w 139039"/>
-              <a:gd name="connsiteY7" fmla="*/ 69520 h 139039"/>
-              <a:gd name="connsiteX8" fmla="*/ 9437 w 139039"/>
-              <a:gd name="connsiteY8" fmla="*/ 78957 h 139039"/>
-              <a:gd name="connsiteX9" fmla="*/ 60082 w 139039"/>
-              <a:gd name="connsiteY9" fmla="*/ 78957 h 139039"/>
-              <a:gd name="connsiteX10" fmla="*/ 60082 w 139039"/>
-              <a:gd name="connsiteY10" fmla="*/ 129602 h 139039"/>
-              <a:gd name="connsiteX11" fmla="*/ 69520 w 139039"/>
-              <a:gd name="connsiteY11" fmla="*/ 139039 h 139039"/>
-              <a:gd name="connsiteX12" fmla="*/ 78957 w 139039"/>
-              <a:gd name="connsiteY12" fmla="*/ 129602 h 139039"/>
-              <a:gd name="connsiteX13" fmla="*/ 78957 w 139039"/>
-              <a:gd name="connsiteY13" fmla="*/ 78957 h 139039"/>
-              <a:gd name="connsiteX14" fmla="*/ 129602 w 139039"/>
-              <a:gd name="connsiteY14" fmla="*/ 78957 h 139039"/>
-              <a:gd name="connsiteX15" fmla="*/ 139039 w 139039"/>
-              <a:gd name="connsiteY15" fmla="*/ 69520 h 139039"/>
-              <a:gd name="connsiteX16" fmla="*/ 129602 w 139039"/>
-              <a:gd name="connsiteY16" fmla="*/ 60082 h 139039"/>
-            </a:gdLst>
-            <a:ahLst/>
-            <a:cxnLst>
-              <a:cxn ang="0">
-                <a:pos x="connsiteX0" y="connsiteY0"/>
-              </a:cxn>
-              <a:cxn ang="0">
-                <a:pos x="connsiteX1" y="connsiteY1"/>
-              </a:cxn>
-              <a:cxn ang="0">
-                <a:pos x="connsiteX2" y="connsiteY2"/>
-              </a:cxn>
-              <a:cxn ang="0">
-                <a:pos x="connsiteX3" y="connsiteY3"/>
-              </a:cxn>
-              <a:cxn ang="0">
-                <a:pos x="connsiteX4" y="connsiteY4"/>
-              </a:cxn>
-              <a:cxn ang="0">
-                <a:pos x="connsiteX5" y="connsiteY5"/>
-              </a:cxn>
-              <a:cxn ang="0">
-                <a:pos x="connsiteX6" y="connsiteY6"/>
-              </a:cxn>
-              <a:cxn ang="0">
-                <a:pos x="connsiteX7" y="connsiteY7"/>
-              </a:cxn>
-              <a:cxn ang="0">
-                <a:pos x="connsiteX8" y="connsiteY8"/>
-              </a:cxn>
-              <a:cxn ang="0">
-                <a:pos x="connsiteX9" y="connsiteY9"/>
-              </a:cxn>
-              <a:cxn ang="0">
-                <a:pos x="connsiteX10" y="connsiteY10"/>
-              </a:cxn>
-              <a:cxn ang="0">
-                <a:pos x="connsiteX11" y="connsiteY11"/>
-              </a:cxn>
-              <a:cxn ang="0">
-                <a:pos x="connsiteX12" y="connsiteY12"/>
-              </a:cxn>
-              <a:cxn ang="0">
-                <a:pos x="connsiteX13" y="connsiteY13"/>
-              </a:cxn>
-              <a:cxn ang="0">
-                <a:pos x="connsiteX14" y="connsiteY14"/>
-              </a:cxn>
-              <a:cxn ang="0">
-                <a:pos x="connsiteX15" y="connsiteY15"/>
-              </a:cxn>
-              <a:cxn ang="0">
-                <a:pos x="connsiteX16" y="connsiteY16"/>
-              </a:cxn>
-            </a:cxnLst>
-            <a:rect l="l" t="t" r="r" b="b"/>
-            <a:pathLst>
-              <a:path w="139039" h="139039">
-                <a:moveTo>
-                  <a:pt x="129602" y="60082"/>
-                </a:moveTo>
-                <a:lnTo>
-                  <a:pt x="78957" y="60082"/>
-                </a:lnTo>
-                <a:lnTo>
-                  <a:pt x="78957" y="9437"/>
-                </a:lnTo>
-                <a:cubicBezTo>
-                  <a:pt x="78957" y="4225"/>
-                  <a:pt x="74731" y="0"/>
-                  <a:pt x="69520" y="0"/>
-                </a:cubicBezTo>
-                <a:cubicBezTo>
-                  <a:pt x="64308" y="0"/>
-                  <a:pt x="60082" y="4225"/>
-                  <a:pt x="60082" y="9437"/>
-                </a:cubicBezTo>
-                <a:lnTo>
-                  <a:pt x="60082" y="60082"/>
-                </a:lnTo>
-                <a:lnTo>
-                  <a:pt x="9437" y="60082"/>
-                </a:lnTo>
-                <a:cubicBezTo>
-                  <a:pt x="4225" y="60082"/>
-                  <a:pt x="0" y="64308"/>
-                  <a:pt x="0" y="69520"/>
-                </a:cubicBezTo>
-                <a:cubicBezTo>
-                  <a:pt x="0" y="74731"/>
-                  <a:pt x="4225" y="78957"/>
-                  <a:pt x="9437" y="78957"/>
-                </a:cubicBezTo>
-                <a:lnTo>
-                  <a:pt x="60082" y="78957"/>
-                </a:lnTo>
-                <a:lnTo>
-                  <a:pt x="60082" y="129602"/>
-                </a:lnTo>
-                <a:cubicBezTo>
-                  <a:pt x="60082" y="134814"/>
-                  <a:pt x="64308" y="139039"/>
-                  <a:pt x="69520" y="139039"/>
-                </a:cubicBezTo>
-                <a:cubicBezTo>
-                  <a:pt x="74731" y="139039"/>
-                  <a:pt x="78957" y="134814"/>
-                  <a:pt x="78957" y="129602"/>
-                </a:cubicBezTo>
-                <a:lnTo>
-                  <a:pt x="78957" y="78957"/>
-                </a:lnTo>
-                <a:lnTo>
-                  <a:pt x="129602" y="78957"/>
-                </a:lnTo>
-                <a:cubicBezTo>
-                  <a:pt x="134814" y="78957"/>
-                  <a:pt x="139039" y="74731"/>
-                  <a:pt x="139039" y="69520"/>
-                </a:cubicBezTo>
-                <a:cubicBezTo>
-                  <a:pt x="139039" y="64308"/>
-                  <a:pt x="134814" y="60082"/>
-                  <a:pt x="129602" y="60082"/>
-                </a:cubicBezTo>
-                <a:close/>
-              </a:path>
-            </a:pathLst>
-          </a:custGeom>
-          <a:solidFill>
-            <a:srgbClr val="FFFFFF"/>
-          </a:solidFill>
-          <a:ln w="603" cap="flat">
-            <a:noFill/>
-            <a:prstDash val="solid"/>
-            <a:miter/>
-          </a:ln>
-        </p:spPr>
-        <p:txBody>
-          <a:bodyPr rtlCol="0" anchor="ctr"/>
-          <a:lstStyle/>
-          <a:p>
-            <a:endParaRPr lang="en-US">
-              <a:solidFill>
-                <a:srgbClr val="FFFFFF"/>
-              </a:solidFill>
-            </a:endParaRPr>
-          </a:p>
-        </p:txBody>
-      </p:sp>
-      <p:sp>
-        <p:nvSpPr>
-          <p:cNvPr id="13" name="Graphic 15">
-            <a:extLst>
-              <a:ext uri="{FF2B5EF4-FFF2-40B4-BE49-F238E27FC236}">
-                <a16:creationId xmlns:a16="http://schemas.microsoft.com/office/drawing/2014/main" id="{AEA7509D-F04F-40CB-A0B3-EEF16499CC9F}"/>
-              </a:ext>
-              <a:ext uri="{C183D7F6-B498-43B3-948B-1728B52AA6E4}">
-                <adec:decorative xmlns:adec="http://schemas.microsoft.com/office/drawing/2017/decorative" val="1"/>
-              </a:ext>
-            </a:extLst>
-          </p:cNvPr>
-          <p:cNvSpPr>
-            <a:spLocks noGrp="1" noRot="1" noChangeAspect="1" noMove="1" noResize="1" noEditPoints="1" noAdjustHandles="1" noChangeArrowheads="1" noChangeShapeType="1" noTextEdit="1"/>
-          </p:cNvSpPr>
-          <p:nvPr>
-            <p:extLst>
-              <p:ext uri="{386F3935-93C4-4BCD-93E2-E3B085C9AB24}">
-                <p16:designElem xmlns:p16="http://schemas.microsoft.com/office/powerpoint/2015/main" val="1"/>
-              </p:ext>
-            </p:extLst>
-          </p:nvPr>
-        </p:nvSpPr>
-        <p:spPr>
-          <a:xfrm>
-            <a:off x="11024834" y="2537201"/>
-            <a:ext cx="127714" cy="127714"/>
-          </a:xfrm>
-          <a:custGeom>
-            <a:avLst/>
-            <a:gdLst>
-              <a:gd name="connsiteX0" fmla="*/ 63857 w 127714"/>
-              <a:gd name="connsiteY0" fmla="*/ 18874 h 127714"/>
-              <a:gd name="connsiteX1" fmla="*/ 108840 w 127714"/>
-              <a:gd name="connsiteY1" fmla="*/ 63857 h 127714"/>
-              <a:gd name="connsiteX2" fmla="*/ 63857 w 127714"/>
-              <a:gd name="connsiteY2" fmla="*/ 108840 h 127714"/>
-              <a:gd name="connsiteX3" fmla="*/ 18874 w 127714"/>
-              <a:gd name="connsiteY3" fmla="*/ 63857 h 127714"/>
-              <a:gd name="connsiteX4" fmla="*/ 63857 w 127714"/>
-              <a:gd name="connsiteY4" fmla="*/ 18874 h 127714"/>
-              <a:gd name="connsiteX5" fmla="*/ 63857 w 127714"/>
-              <a:gd name="connsiteY5" fmla="*/ 0 h 127714"/>
-              <a:gd name="connsiteX6" fmla="*/ 0 w 127714"/>
-              <a:gd name="connsiteY6" fmla="*/ 63857 h 127714"/>
-              <a:gd name="connsiteX7" fmla="*/ 63857 w 127714"/>
-              <a:gd name="connsiteY7" fmla="*/ 127714 h 127714"/>
-              <a:gd name="connsiteX8" fmla="*/ 127714 w 127714"/>
-              <a:gd name="connsiteY8" fmla="*/ 63857 h 127714"/>
-              <a:gd name="connsiteX9" fmla="*/ 63857 w 127714"/>
-              <a:gd name="connsiteY9" fmla="*/ 0 h 127714"/>
-            </a:gdLst>
-            <a:ahLst/>
-            <a:cxnLst>
-              <a:cxn ang="0">
-                <a:pos x="connsiteX0" y="connsiteY0"/>
-              </a:cxn>
-              <a:cxn ang="0">
-                <a:pos x="connsiteX1" y="connsiteY1"/>
-              </a:cxn>
-              <a:cxn ang="0">
-                <a:pos x="connsiteX2" y="connsiteY2"/>
-              </a:cxn>
-              <a:cxn ang="0">
-                <a:pos x="connsiteX3" y="connsiteY3"/>
-              </a:cxn>
-              <a:cxn ang="0">
-                <a:pos x="connsiteX4" y="connsiteY4"/>
-              </a:cxn>
-              <a:cxn ang="0">
-                <a:pos x="connsiteX5" y="connsiteY5"/>
-              </a:cxn>
-              <a:cxn ang="0">
-                <a:pos x="connsiteX6" y="connsiteY6"/>
-              </a:cxn>
-              <a:cxn ang="0">
-                <a:pos x="connsiteX7" y="connsiteY7"/>
-              </a:cxn>
-              <a:cxn ang="0">
-                <a:pos x="connsiteX8" y="connsiteY8"/>
-              </a:cxn>
-              <a:cxn ang="0">
-                <a:pos x="connsiteX9" y="connsiteY9"/>
-              </a:cxn>
-            </a:cxnLst>
-            <a:rect l="l" t="t" r="r" b="b"/>
-            <a:pathLst>
-              <a:path w="127714" h="127714">
-                <a:moveTo>
-                  <a:pt x="63857" y="18874"/>
-                </a:moveTo>
-                <a:cubicBezTo>
-                  <a:pt x="88700" y="18874"/>
-                  <a:pt x="108840" y="39014"/>
-                  <a:pt x="108840" y="63857"/>
-                </a:cubicBezTo>
-                <a:cubicBezTo>
-                  <a:pt x="108840" y="88700"/>
-                  <a:pt x="88700" y="108840"/>
-                  <a:pt x="63857" y="108840"/>
-                </a:cubicBezTo>
-                <a:cubicBezTo>
-                  <a:pt x="39014" y="108840"/>
-                  <a:pt x="18874" y="88700"/>
-                  <a:pt x="18874" y="63857"/>
-                </a:cubicBezTo>
-                <a:cubicBezTo>
-                  <a:pt x="18898" y="39024"/>
-                  <a:pt x="39024" y="18898"/>
-                  <a:pt x="63857" y="18874"/>
-                </a:cubicBezTo>
-                <a:moveTo>
-                  <a:pt x="63857" y="0"/>
-                </a:moveTo>
-                <a:cubicBezTo>
-                  <a:pt x="28590" y="0"/>
-                  <a:pt x="0" y="28590"/>
-                  <a:pt x="0" y="63857"/>
-                </a:cubicBezTo>
-                <a:cubicBezTo>
-                  <a:pt x="0" y="99124"/>
-                  <a:pt x="28590" y="127714"/>
-                  <a:pt x="63857" y="127714"/>
-                </a:cubicBezTo>
-                <a:cubicBezTo>
-                  <a:pt x="99124" y="127714"/>
-                  <a:pt x="127714" y="99124"/>
-                  <a:pt x="127714" y="63857"/>
-                </a:cubicBezTo>
-                <a:cubicBezTo>
-                  <a:pt x="127714" y="28590"/>
-                  <a:pt x="99124" y="0"/>
-                  <a:pt x="63857" y="0"/>
-                </a:cubicBezTo>
-                <a:close/>
-              </a:path>
-            </a:pathLst>
-          </a:custGeom>
-          <a:solidFill>
-            <a:srgbClr val="FFFFFF"/>
-          </a:solidFill>
-          <a:ln w="610" cap="flat">
-            <a:noFill/>
-            <a:prstDash val="solid"/>
-            <a:miter/>
-          </a:ln>
-        </p:spPr>
-        <p:txBody>
-          <a:bodyPr rtlCol="0" anchor="ctr"/>
-          <a:lstStyle/>
-          <a:p>
-            <a:endParaRPr lang="en-US">
-              <a:solidFill>
-                <a:srgbClr val="FFFFFF"/>
-              </a:solidFill>
-            </a:endParaRPr>
-          </a:p>
-        </p:txBody>
-      </p:sp>
-      <p:sp>
-        <p:nvSpPr>
-          <p:cNvPr id="20" name="Graphic 21">
-            <a:extLst>
-              <a:ext uri="{FF2B5EF4-FFF2-40B4-BE49-F238E27FC236}">
-                <a16:creationId xmlns:a16="http://schemas.microsoft.com/office/drawing/2014/main" id="{C39ADB8F-D187-49D7-BDCF-C1B6DC727068}"/>
-              </a:ext>
-              <a:ext uri="{C183D7F6-B498-43B3-948B-1728B52AA6E4}">
-                <adec:decorative xmlns:adec="http://schemas.microsoft.com/office/drawing/2017/decorative" val="1"/>
-              </a:ext>
-            </a:extLst>
-          </p:cNvPr>
-          <p:cNvSpPr>
-            <a:spLocks noGrp="1" noRot="1" noChangeAspect="1" noMove="1" noResize="1" noEditPoints="1" noAdjustHandles="1" noChangeArrowheads="1" noChangeShapeType="1" noTextEdit="1"/>
-          </p:cNvSpPr>
-          <p:nvPr>
-            <p:extLst>
-              <p:ext uri="{386F3935-93C4-4BCD-93E2-E3B085C9AB24}">
-                <p16:designElem xmlns:p16="http://schemas.microsoft.com/office/powerpoint/2015/main" val="1"/>
-              </p:ext>
-            </p:extLst>
-          </p:nvPr>
-        </p:nvSpPr>
-        <p:spPr>
-          <a:xfrm>
-            <a:off x="1064053" y="2832967"/>
-            <a:ext cx="95759" cy="95759"/>
-          </a:xfrm>
-          <a:custGeom>
-            <a:avLst/>
-            <a:gdLst>
-              <a:gd name="connsiteX0" fmla="*/ 95759 w 95759"/>
-              <a:gd name="connsiteY0" fmla="*/ 47880 h 95759"/>
-              <a:gd name="connsiteX1" fmla="*/ 47880 w 95759"/>
-              <a:gd name="connsiteY1" fmla="*/ 95759 h 95759"/>
-              <a:gd name="connsiteX2" fmla="*/ 0 w 95759"/>
-              <a:gd name="connsiteY2" fmla="*/ 47880 h 95759"/>
-              <a:gd name="connsiteX3" fmla="*/ 47880 w 95759"/>
-              <a:gd name="connsiteY3" fmla="*/ 0 h 95759"/>
-              <a:gd name="connsiteX4" fmla="*/ 95759 w 95759"/>
-              <a:gd name="connsiteY4" fmla="*/ 47880 h 95759"/>
-            </a:gdLst>
-            <a:ahLst/>
-            <a:cxnLst>
-              <a:cxn ang="0">
-                <a:pos x="connsiteX0" y="connsiteY0"/>
-              </a:cxn>
-              <a:cxn ang="0">
-                <a:pos x="connsiteX1" y="connsiteY1"/>
-              </a:cxn>
-              <a:cxn ang="0">
-                <a:pos x="connsiteX2" y="connsiteY2"/>
-              </a:cxn>
-              <a:cxn ang="0">
-                <a:pos x="connsiteX3" y="connsiteY3"/>
-              </a:cxn>
-              <a:cxn ang="0">
-                <a:pos x="connsiteX4" y="connsiteY4"/>
-              </a:cxn>
-            </a:cxnLst>
-            <a:rect l="l" t="t" r="r" b="b"/>
-            <a:pathLst>
-              <a:path w="95759" h="95759">
-                <a:moveTo>
-                  <a:pt x="95759" y="47880"/>
-                </a:moveTo>
-                <a:cubicBezTo>
-                  <a:pt x="95759" y="74323"/>
-                  <a:pt x="74323" y="95759"/>
-                  <a:pt x="47880" y="95759"/>
-                </a:cubicBezTo>
-                <a:cubicBezTo>
-                  <a:pt x="21436" y="95759"/>
-                  <a:pt x="0" y="74323"/>
-                  <a:pt x="0" y="47880"/>
-                </a:cubicBezTo>
-                <a:cubicBezTo>
-                  <a:pt x="0" y="21436"/>
-                  <a:pt x="21436" y="0"/>
-                  <a:pt x="47880" y="0"/>
-                </a:cubicBezTo>
-                <a:cubicBezTo>
-                  <a:pt x="74323" y="0"/>
-                  <a:pt x="95759" y="21436"/>
-                  <a:pt x="95759" y="47880"/>
-                </a:cubicBezTo>
-                <a:close/>
-              </a:path>
-            </a:pathLst>
-          </a:custGeom>
-          <a:solidFill>
-            <a:srgbClr val="FFFFFF"/>
-          </a:solidFill>
-          <a:ln w="469" cap="flat">
-            <a:noFill/>
-            <a:prstDash val="solid"/>
-            <a:miter/>
-          </a:ln>
-        </p:spPr>
-        <p:txBody>
-          <a:bodyPr rtlCol="0" anchor="ctr"/>
-          <a:lstStyle/>
-          <a:p>
-            <a:endParaRPr lang="en-US">
-              <a:solidFill>
-                <a:srgbClr val="FFFFFF"/>
-              </a:solidFill>
-            </a:endParaRPr>
-          </a:p>
-        </p:txBody>
-      </p:sp>
-      <p:sp>
-        <p:nvSpPr>
-          <p:cNvPr id="22" name="Graphic 12">
-            <a:extLst>
-              <a:ext uri="{FF2B5EF4-FFF2-40B4-BE49-F238E27FC236}">
-                <a16:creationId xmlns:a16="http://schemas.microsoft.com/office/drawing/2014/main" id="{712D4376-A578-4FF1-94FC-245E7A6A489F}"/>
-              </a:ext>
-              <a:ext uri="{C183D7F6-B498-43B3-948B-1728B52AA6E4}">
-                <adec:decorative xmlns:adec="http://schemas.microsoft.com/office/drawing/2017/decorative" val="1"/>
-              </a:ext>
-            </a:extLst>
-          </p:cNvPr>
-          <p:cNvSpPr>
-            <a:spLocks noGrp="1" noRot="1" noChangeAspect="1" noMove="1" noResize="1" noEditPoints="1" noAdjustHandles="1" noChangeArrowheads="1" noChangeShapeType="1" noTextEdit="1"/>
-          </p:cNvSpPr>
-          <p:nvPr>
-            <p:extLst>
-              <p:ext uri="{386F3935-93C4-4BCD-93E2-E3B085C9AB24}">
-                <p16:designElem xmlns:p16="http://schemas.microsoft.com/office/powerpoint/2015/main" val="1"/>
-              </p:ext>
-            </p:extLst>
-          </p:nvPr>
-        </p:nvSpPr>
-        <p:spPr>
-          <a:xfrm>
-            <a:off x="10772266" y="2803988"/>
-            <a:ext cx="91138" cy="91138"/>
-          </a:xfrm>
-          <a:custGeom>
-            <a:avLst/>
-            <a:gdLst>
-              <a:gd name="connsiteX0" fmla="*/ 91138 w 91138"/>
-              <a:gd name="connsiteY0" fmla="*/ 45569 h 91138"/>
-              <a:gd name="connsiteX1" fmla="*/ 45569 w 91138"/>
-              <a:gd name="connsiteY1" fmla="*/ 91138 h 91138"/>
-              <a:gd name="connsiteX2" fmla="*/ 0 w 91138"/>
-              <a:gd name="connsiteY2" fmla="*/ 45569 h 91138"/>
-              <a:gd name="connsiteX3" fmla="*/ 45569 w 91138"/>
-              <a:gd name="connsiteY3" fmla="*/ 0 h 91138"/>
-              <a:gd name="connsiteX4" fmla="*/ 91138 w 91138"/>
-              <a:gd name="connsiteY4" fmla="*/ 45569 h 91138"/>
-            </a:gdLst>
-            <a:ahLst/>
-            <a:cxnLst>
-              <a:cxn ang="0">
-                <a:pos x="connsiteX0" y="connsiteY0"/>
-              </a:cxn>
-              <a:cxn ang="0">
-                <a:pos x="connsiteX1" y="connsiteY1"/>
-              </a:cxn>
-              <a:cxn ang="0">
-                <a:pos x="connsiteX2" y="connsiteY2"/>
-              </a:cxn>
-              <a:cxn ang="0">
-                <a:pos x="connsiteX3" y="connsiteY3"/>
-              </a:cxn>
-              <a:cxn ang="0">
-                <a:pos x="connsiteX4" y="connsiteY4"/>
-              </a:cxn>
-            </a:cxnLst>
-            <a:rect l="l" t="t" r="r" b="b"/>
-            <a:pathLst>
-              <a:path w="91138" h="91138">
-                <a:moveTo>
-                  <a:pt x="91138" y="45569"/>
-                </a:moveTo>
-                <a:cubicBezTo>
-                  <a:pt x="91138" y="70736"/>
-                  <a:pt x="70736" y="91138"/>
-                  <a:pt x="45569" y="91138"/>
-                </a:cubicBezTo>
-                <a:cubicBezTo>
-                  <a:pt x="20402" y="91138"/>
-                  <a:pt x="0" y="70736"/>
-                  <a:pt x="0" y="45569"/>
-                </a:cubicBezTo>
-                <a:cubicBezTo>
-                  <a:pt x="0" y="20402"/>
-                  <a:pt x="20402" y="0"/>
-                  <a:pt x="45569" y="0"/>
-                </a:cubicBezTo>
-                <a:cubicBezTo>
-                  <a:pt x="70736" y="0"/>
-                  <a:pt x="91138" y="20402"/>
-                  <a:pt x="91138" y="45569"/>
-                </a:cubicBezTo>
-                <a:close/>
-              </a:path>
-            </a:pathLst>
-          </a:custGeom>
-          <a:solidFill>
-            <a:srgbClr val="FFFFFF"/>
-          </a:solidFill>
-          <a:ln w="422" cap="flat">
-            <a:noFill/>
-            <a:prstDash val="solid"/>
-            <a:miter/>
-          </a:ln>
-        </p:spPr>
-        <p:txBody>
-          <a:bodyPr rtlCol="0" anchor="ctr"/>
-          <a:lstStyle/>
-          <a:p>
-            <a:endParaRPr lang="en-US">
-              <a:solidFill>
-                <a:srgbClr val="FFFFFF"/>
-              </a:solidFill>
-            </a:endParaRPr>
-          </a:p>
-        </p:txBody>
-      </p:sp>
-      <p:sp>
-        <p:nvSpPr>
-          <p:cNvPr id="19" name="Graphic 23">
-            <a:extLst>
-              <a:ext uri="{FF2B5EF4-FFF2-40B4-BE49-F238E27FC236}">
-                <a16:creationId xmlns:a16="http://schemas.microsoft.com/office/drawing/2014/main" id="{3FBAD350-5664-4811-A208-657FB882D350}"/>
-              </a:ext>
-              <a:ext uri="{C183D7F6-B498-43B3-948B-1728B52AA6E4}">
-                <adec:decorative xmlns:adec="http://schemas.microsoft.com/office/drawing/2017/decorative" val="1"/>
-              </a:ext>
-            </a:extLst>
-          </p:cNvPr>
-          <p:cNvSpPr>
-            <a:spLocks noGrp="1" noRot="1" noChangeAspect="1" noMove="1" noResize="1" noEditPoints="1" noAdjustHandles="1" noChangeArrowheads="1" noChangeShapeType="1" noTextEdit="1"/>
-          </p:cNvSpPr>
-          <p:nvPr>
-            <p:extLst>
-              <p:ext uri="{386F3935-93C4-4BCD-93E2-E3B085C9AB24}">
-                <p16:designElem xmlns:p16="http://schemas.microsoft.com/office/powerpoint/2015/main" val="1"/>
-              </p:ext>
-            </p:extLst>
-          </p:nvPr>
-        </p:nvSpPr>
-        <p:spPr>
-          <a:xfrm>
-            <a:off x="1413405" y="3242499"/>
-            <a:ext cx="108625" cy="108625"/>
-          </a:xfrm>
-          <a:custGeom>
-            <a:avLst/>
-            <a:gdLst>
-              <a:gd name="connsiteX0" fmla="*/ 54313 w 108625"/>
-              <a:gd name="connsiteY0" fmla="*/ 16053 h 108625"/>
-              <a:gd name="connsiteX1" fmla="*/ 92572 w 108625"/>
-              <a:gd name="connsiteY1" fmla="*/ 54313 h 108625"/>
-              <a:gd name="connsiteX2" fmla="*/ 54313 w 108625"/>
-              <a:gd name="connsiteY2" fmla="*/ 92572 h 108625"/>
-              <a:gd name="connsiteX3" fmla="*/ 16053 w 108625"/>
-              <a:gd name="connsiteY3" fmla="*/ 54313 h 108625"/>
-              <a:gd name="connsiteX4" fmla="*/ 54313 w 108625"/>
-              <a:gd name="connsiteY4" fmla="*/ 16053 h 108625"/>
-              <a:gd name="connsiteX5" fmla="*/ 54313 w 108625"/>
-              <a:gd name="connsiteY5" fmla="*/ 0 h 108625"/>
-              <a:gd name="connsiteX6" fmla="*/ 0 w 108625"/>
-              <a:gd name="connsiteY6" fmla="*/ 54313 h 108625"/>
-              <a:gd name="connsiteX7" fmla="*/ 54313 w 108625"/>
-              <a:gd name="connsiteY7" fmla="*/ 108625 h 108625"/>
-              <a:gd name="connsiteX8" fmla="*/ 108625 w 108625"/>
-              <a:gd name="connsiteY8" fmla="*/ 54313 h 108625"/>
-              <a:gd name="connsiteX9" fmla="*/ 54313 w 108625"/>
-              <a:gd name="connsiteY9" fmla="*/ 0 h 108625"/>
-            </a:gdLst>
-            <a:ahLst/>
-            <a:cxnLst>
-              <a:cxn ang="0">
-                <a:pos x="connsiteX0" y="connsiteY0"/>
-              </a:cxn>
-              <a:cxn ang="0">
-                <a:pos x="connsiteX1" y="connsiteY1"/>
-              </a:cxn>
-              <a:cxn ang="0">
-                <a:pos x="connsiteX2" y="connsiteY2"/>
-              </a:cxn>
-              <a:cxn ang="0">
-                <a:pos x="connsiteX3" y="connsiteY3"/>
-              </a:cxn>
-              <a:cxn ang="0">
-                <a:pos x="connsiteX4" y="connsiteY4"/>
-              </a:cxn>
-              <a:cxn ang="0">
-                <a:pos x="connsiteX5" y="connsiteY5"/>
-              </a:cxn>
-              <a:cxn ang="0">
-                <a:pos x="connsiteX6" y="connsiteY6"/>
-              </a:cxn>
-              <a:cxn ang="0">
-                <a:pos x="connsiteX7" y="connsiteY7"/>
-              </a:cxn>
-              <a:cxn ang="0">
-                <a:pos x="connsiteX8" y="connsiteY8"/>
-              </a:cxn>
-              <a:cxn ang="0">
-                <a:pos x="connsiteX9" y="connsiteY9"/>
-              </a:cxn>
-            </a:cxnLst>
-            <a:rect l="l" t="t" r="r" b="b"/>
-            <a:pathLst>
-              <a:path w="108625" h="108625">
-                <a:moveTo>
-                  <a:pt x="54313" y="16053"/>
-                </a:moveTo>
-                <a:cubicBezTo>
-                  <a:pt x="75442" y="16053"/>
-                  <a:pt x="92572" y="33182"/>
-                  <a:pt x="92572" y="54313"/>
-                </a:cubicBezTo>
-                <a:cubicBezTo>
-                  <a:pt x="92572" y="75442"/>
-                  <a:pt x="75442" y="92572"/>
-                  <a:pt x="54313" y="92572"/>
-                </a:cubicBezTo>
-                <a:cubicBezTo>
-                  <a:pt x="33182" y="92572"/>
-                  <a:pt x="16053" y="75442"/>
-                  <a:pt x="16053" y="54313"/>
-                </a:cubicBezTo>
-                <a:cubicBezTo>
-                  <a:pt x="16074" y="33191"/>
-                  <a:pt x="33191" y="16074"/>
-                  <a:pt x="54313" y="16053"/>
-                </a:cubicBezTo>
-                <a:moveTo>
-                  <a:pt x="54313" y="0"/>
-                </a:moveTo>
-                <a:cubicBezTo>
-                  <a:pt x="24317" y="0"/>
-                  <a:pt x="0" y="24317"/>
-                  <a:pt x="0" y="54313"/>
-                </a:cubicBezTo>
-                <a:cubicBezTo>
-                  <a:pt x="0" y="84309"/>
-                  <a:pt x="24317" y="108625"/>
-                  <a:pt x="54313" y="108625"/>
-                </a:cubicBezTo>
-                <a:cubicBezTo>
-                  <a:pt x="84309" y="108625"/>
-                  <a:pt x="108625" y="84309"/>
-                  <a:pt x="108625" y="54313"/>
-                </a:cubicBezTo>
-                <a:cubicBezTo>
-                  <a:pt x="108625" y="24317"/>
-                  <a:pt x="84309" y="0"/>
-                  <a:pt x="54313" y="0"/>
-                </a:cubicBezTo>
-                <a:close/>
-              </a:path>
-            </a:pathLst>
-          </a:custGeom>
-          <a:solidFill>
-            <a:srgbClr val="FFFFFF"/>
-          </a:solidFill>
-          <a:ln w="516" cap="flat">
-            <a:noFill/>
-            <a:prstDash val="solid"/>
-            <a:miter/>
-          </a:ln>
-        </p:spPr>
-        <p:txBody>
-          <a:bodyPr rtlCol="0" anchor="ctr"/>
-          <a:lstStyle/>
-          <a:p>
-            <a:endParaRPr lang="en-US">
-              <a:solidFill>
-                <a:srgbClr val="FFFFFF"/>
-              </a:solidFill>
-            </a:endParaRPr>
-          </a:p>
-        </p:txBody>
-      </p:sp>
-      <p:cxnSp>
-        <p:nvCxnSpPr>
-          <p:cNvPr id="21" name="Straight Connector 20">
-            <a:extLst>
-              <a:ext uri="{FF2B5EF4-FFF2-40B4-BE49-F238E27FC236}">
-                <a16:creationId xmlns:a16="http://schemas.microsoft.com/office/drawing/2014/main" id="{56020367-4FD5-4596-8E10-C5F095CD8DBF}"/>
-              </a:ext>
-              <a:ext uri="{C183D7F6-B498-43B3-948B-1728B52AA6E4}">
-                <adec:decorative xmlns:adec="http://schemas.microsoft.com/office/drawing/2017/decorative" val="1"/>
-              </a:ext>
-            </a:extLst>
-          </p:cNvPr>
-          <p:cNvCxnSpPr>
-            <a:cxnSpLocks noGrp="1" noRot="1" noChangeAspect="1" noMove="1" noResize="1" noEditPoints="1" noAdjustHandles="1" noChangeArrowheads="1" noChangeShapeType="1"/>
-          </p:cNvCxnSpPr>
-          <p:nvPr>
-            <p:extLst>
-              <p:ext uri="{386F3935-93C4-4BCD-93E2-E3B085C9AB24}">
-                <p16:designElem xmlns:p16="http://schemas.microsoft.com/office/powerpoint/2015/main" val="1"/>
-              </p:ext>
-            </p:extLst>
-          </p:nvPr>
-        </p:nvCxnSpPr>
-        <p:spPr>
-          <a:xfrm>
-            <a:off x="0" y="5831729"/>
-            <a:ext cx="12188952" cy="0"/>
-          </a:xfrm>
-          <a:prstGeom prst="line">
-            <a:avLst/>
-          </a:prstGeom>
-          <a:ln w="25400" cap="sq">
-            <a:solidFill>
-              <a:srgbClr val="FFFFFF"/>
-            </a:solidFill>
-            <a:bevel/>
-          </a:ln>
-        </p:spPr>
-        <p:style>
-          <a:lnRef idx="1">
-            <a:schemeClr val="accent1"/>
-          </a:lnRef>
-          <a:fillRef idx="0">
-            <a:schemeClr val="accent1"/>
-          </a:fillRef>
-          <a:effectRef idx="0">
-            <a:schemeClr val="accent1"/>
-          </a:effectRef>
-          <a:fontRef idx="minor">
-            <a:schemeClr val="tx1"/>
-          </a:fontRef>
-        </p:style>
-      </p:cxnSp>
-    </p:spTree>
-    <p:extLst>
-      <p:ext uri="{BB962C8B-B14F-4D97-AF65-F5344CB8AC3E}">
-        <p14:creationId xmlns:p14="http://schemas.microsoft.com/office/powerpoint/2010/main" val="1577846891"/>
       </p:ext>
     </p:extLst>
   </p:cSld>

</xml_diff>